<commit_message>
update the latest ppt
</commit_message>
<xml_diff>
--- a/week_02/OptMCTS/OptMCTS_Report.pptx
+++ b/week_02/OptMCTS/OptMCTS_Report.pptx
@@ -1368,7 +1368,217 @@
         <p:spPr>
           <a:xfrm>
             <a:off x="640080" y="3063240"/>
-            <a:ext cx="8229600" cy="411480"/>
+            <a:ext cx="8229600" cy="868680"/>
+          </a:xfrm>
+          <a:prstGeom prst="rect">
+            <a:avLst/>
+          </a:prstGeom>
+          <a:noFill/>
+          <a:ln/>
+        </p:spPr>
+        <p:txBody>
+          <a:bodyPr wrap="square" lIns="0" tIns="0" rIns="0" bIns="0" rtlCol="0" anchor="ctr"/>
+          <a:lstStyle/>
+          <a:p>
+            <a:r>
+              <a:rPr lang="en-US" sz="1300" b="1" dirty="0">
+                <a:solidFill>
+                  <a:srgbClr val="F59E0B"/>
+                </a:solidFill>
+                <a:latin typeface="Calibri" pitchFamily="34" charset="0"/>
+                <a:ea typeface="Calibri" pitchFamily="34" charset="-122"/>
+                <a:cs typeface="Calibri" pitchFamily="34" charset="-120"/>
+              </a:rPr>
+              <a:t>Model: </a:t>
+            </a:r>
+            <a:r>
+              <a:rPr lang="en-US" sz="1300" dirty="0">
+                <a:solidFill>
+                  <a:srgbClr val="CADCFC"/>
+                </a:solidFill>
+                <a:latin typeface="Calibri" pitchFamily="34" charset="0"/>
+                <a:ea typeface="Calibri" pitchFamily="34" charset="-122"/>
+                <a:cs typeface="Calibri" pitchFamily="34" charset="-120"/>
+              </a:rPr>
+              <a:t>GPT-4o-mini  </a:t>
+            </a:r>
+            <a:r>
+              <a:rPr lang="en-US" sz="1300" dirty="0">
+                <a:solidFill>
+                  <a:srgbClr val="64748B"/>
+                </a:solidFill>
+                <a:latin typeface="Calibri" pitchFamily="34" charset="0"/>
+                <a:ea typeface="Calibri" pitchFamily="34" charset="-122"/>
+                <a:cs typeface="Calibri" pitchFamily="34" charset="-120"/>
+              </a:rPr>
+              <a:t>  |  </a:t>
+            </a:r>
+            <a:r>
+              <a:rPr lang="en-US" sz="1300" b="1" dirty="0">
+                <a:solidFill>
+                  <a:srgbClr val="F59E0B"/>
+                </a:solidFill>
+                <a:latin typeface="Calibri" pitchFamily="34" charset="0"/>
+                <a:ea typeface="Calibri" pitchFamily="34" charset="-122"/>
+                <a:cs typeface="Calibri" pitchFamily="34" charset="-120"/>
+              </a:rPr>
+              <a:t>Paper: </a:t>
+            </a:r>
+            <a:r>
+              <a:rPr lang="en-US" sz="1300" dirty="0">
+                <a:solidFill>
+                  <a:srgbClr val="CADCFC"/>
+                </a:solidFill>
+                <a:latin typeface="Calibri" pitchFamily="34" charset="0"/>
+                <a:ea typeface="Calibri" pitchFamily="34" charset="-122"/>
+                <a:cs typeface="Calibri" pitchFamily="34" charset="-120"/>
+              </a:rPr>
+              <a:t>SolverLLM (NeurIPS 2025)  </a:t>
+            </a:r>
+            <a:r>
+              <a:rPr lang="en-US" sz="1300" dirty="0">
+                <a:solidFill>
+                  <a:srgbClr val="64748B"/>
+                </a:solidFill>
+                <a:latin typeface="Calibri" pitchFamily="34" charset="0"/>
+                <a:ea typeface="Calibri" pitchFamily="34" charset="-122"/>
+                <a:cs typeface="Calibri" pitchFamily="34" charset="-120"/>
+              </a:rPr>
+              <a:t>  |  </a:t>
+            </a:r>
+            <a:r>
+              <a:rPr lang="en-US" sz="1300" b="1" dirty="0">
+                <a:solidFill>
+                  <a:srgbClr val="F59E0B"/>
+                </a:solidFill>
+                <a:latin typeface="Calibri" pitchFamily="34" charset="0"/>
+                <a:ea typeface="Calibri" pitchFamily="34" charset="-122"/>
+                <a:cs typeface="Calibri" pitchFamily="34" charset="-120"/>
+              </a:rPr>
+              <a:t>Datasets: </a:t>
+            </a:r>
+            <a:r>
+              <a:rPr lang="en-US" sz="1300" dirty="0">
+                <a:solidFill>
+                  <a:srgbClr val="CADCFC"/>
+                </a:solidFill>
+                <a:latin typeface="Calibri" pitchFamily="34" charset="0"/>
+                <a:ea typeface="Calibri" pitchFamily="34" charset="-122"/>
+                <a:cs typeface="Calibri" pitchFamily="34" charset="-120"/>
+              </a:rPr>
+              <a:t>9 benchmarks, 2,634 problems</a:t>
+            </a:r>
+            <a:br>
+              <a:rPr lang="en-US" sz="1300" dirty="0">
+                <a:solidFill>
+                  <a:srgbClr val="CADCFC"/>
+                </a:solidFill>
+                <a:latin typeface="Calibri" pitchFamily="34" charset="0"/>
+                <a:ea typeface="Calibri" pitchFamily="34" charset="-122"/>
+                <a:cs typeface="Calibri" pitchFamily="34" charset="-120"/>
+              </a:rPr>
+            </a:br>
+            <a:br>
+              <a:rPr lang="en-US" sz="1300" dirty="0">
+                <a:solidFill>
+                  <a:srgbClr val="CADCFC"/>
+                </a:solidFill>
+                <a:latin typeface="Calibri" pitchFamily="34" charset="0"/>
+                <a:ea typeface="Calibri" pitchFamily="34" charset="-122"/>
+                <a:cs typeface="Calibri" pitchFamily="34" charset="-120"/>
+              </a:rPr>
+            </a:br>
+            <a:r>
+              <a:rPr lang="en-US" sz="1300" dirty="0">
+                <a:solidFill>
+                  <a:srgbClr val="CADCFC"/>
+                </a:solidFill>
+                <a:latin typeface="Calibri" pitchFamily="34" charset="0"/>
+                <a:ea typeface="Calibri" pitchFamily="34" charset="-122"/>
+                <a:cs typeface="Calibri" pitchFamily="34" charset="-120"/>
+              </a:rPr>
+              <a:t>Reference</a:t>
+            </a:r>
+            <a:r>
+              <a:rPr lang="zh-CN" altLang="en-US" sz="1300" dirty="0">
+                <a:solidFill>
+                  <a:srgbClr val="CADCFC"/>
+                </a:solidFill>
+                <a:latin typeface="Calibri" pitchFamily="34" charset="0"/>
+                <a:ea typeface="Calibri" pitchFamily="34" charset="-122"/>
+                <a:cs typeface="Calibri" pitchFamily="34" charset="-120"/>
+              </a:rPr>
+              <a:t>： </a:t>
+            </a:r>
+            <a:r>
+              <a:rPr lang="en-US" altLang="zh-CN" sz="1300" dirty="0">
+                <a:solidFill>
+                  <a:srgbClr val="CADCFC"/>
+                </a:solidFill>
+                <a:latin typeface="Calibri" pitchFamily="34" charset="0"/>
+                <a:ea typeface="Calibri" pitchFamily="34" charset="-122"/>
+                <a:cs typeface="Calibri" pitchFamily="34" charset="-120"/>
+              </a:rPr>
+              <a:t> https://</a:t>
+            </a:r>
+            <a:r>
+              <a:rPr lang="en-US" altLang="zh-CN" sz="1300" dirty="0" err="1">
+                <a:solidFill>
+                  <a:srgbClr val="CADCFC"/>
+                </a:solidFill>
+                <a:latin typeface="Calibri" pitchFamily="34" charset="0"/>
+                <a:ea typeface="Calibri" pitchFamily="34" charset="-122"/>
+                <a:cs typeface="Calibri" pitchFamily="34" charset="-120"/>
+              </a:rPr>
+              <a:t>neurips.cc</a:t>
+            </a:r>
+            <a:r>
+              <a:rPr lang="en-US" altLang="zh-CN" sz="1300" dirty="0">
+                <a:solidFill>
+                  <a:srgbClr val="CADCFC"/>
+                </a:solidFill>
+                <a:latin typeface="Calibri" pitchFamily="34" charset="0"/>
+                <a:ea typeface="Calibri" pitchFamily="34" charset="-122"/>
+                <a:cs typeface="Calibri" pitchFamily="34" charset="-120"/>
+              </a:rPr>
+              <a:t>/virtual/2025/loc/</a:t>
+            </a:r>
+            <a:r>
+              <a:rPr lang="en-US" altLang="zh-CN" sz="1300" dirty="0" err="1">
+                <a:solidFill>
+                  <a:srgbClr val="CADCFC"/>
+                </a:solidFill>
+                <a:latin typeface="Calibri" pitchFamily="34" charset="0"/>
+                <a:ea typeface="Calibri" pitchFamily="34" charset="-122"/>
+                <a:cs typeface="Calibri" pitchFamily="34" charset="-120"/>
+              </a:rPr>
+              <a:t>san-diego</a:t>
+            </a:r>
+            <a:r>
+              <a:rPr lang="en-US" altLang="zh-CN" sz="1300" dirty="0">
+                <a:solidFill>
+                  <a:srgbClr val="CADCFC"/>
+                </a:solidFill>
+                <a:latin typeface="Calibri" pitchFamily="34" charset="0"/>
+                <a:ea typeface="Calibri" pitchFamily="34" charset="-122"/>
+                <a:cs typeface="Calibri" pitchFamily="34" charset="-120"/>
+              </a:rPr>
+              <a:t>/poster/116215</a:t>
+            </a:r>
+            <a:endParaRPr lang="en-US" sz="1300" dirty="0"/>
+          </a:p>
+        </p:txBody>
+      </p:sp>
+      <p:sp>
+        <p:nvSpPr>
+          <p:cNvPr id="8" name="Text 6"/>
+          <p:cNvSpPr/>
+          <p:nvPr/>
+        </p:nvSpPr>
+        <p:spPr>
+          <a:xfrm>
+            <a:off x="640080" y="4663440"/>
+            <a:ext cx="4572000" cy="320040"/>
           </a:xfrm>
           <a:prstGeom prst="rect">
             <a:avLst/>
@@ -1384,29 +1594,7 @@
               <a:buNone/>
             </a:pPr>
             <a:r>
-              <a:rPr lang="en-US" sz="1300" b="1" dirty="0">
-                <a:solidFill>
-                  <a:srgbClr val="F59E0B"/>
-                </a:solidFill>
-                <a:latin typeface="Calibri" pitchFamily="34" charset="0"/>
-                <a:ea typeface="Calibri" pitchFamily="34" charset="-122"/>
-                <a:cs typeface="Calibri" pitchFamily="34" charset="-120"/>
-              </a:rPr>
-              <a:t>Model: </a:t>
-            </a:r>
-            <a:r>
-              <a:rPr lang="en-US" sz="1300" dirty="0">
-                <a:solidFill>
-                  <a:srgbClr val="CADCFC"/>
-                </a:solidFill>
-                <a:latin typeface="Calibri" pitchFamily="34" charset="0"/>
-                <a:ea typeface="Calibri" pitchFamily="34" charset="-122"/>
-                <a:cs typeface="Calibri" pitchFamily="34" charset="-120"/>
-              </a:rPr>
-              <a:t>GPT-4o-mini  </a:t>
-            </a:r>
-            <a:r>
-              <a:rPr lang="en-US" sz="1300" dirty="0">
+              <a:rPr lang="en-US" sz="1100" dirty="0">
                 <a:solidFill>
                   <a:srgbClr val="64748B"/>
                 </a:solidFill>
@@ -1414,32 +1602,10 @@
                 <a:ea typeface="Calibri" pitchFamily="34" charset="-122"/>
                 <a:cs typeface="Calibri" pitchFamily="34" charset="-120"/>
               </a:rPr>
-              <a:t>  |  </a:t>
-            </a:r>
-            <a:r>
-              <a:rPr lang="en-US" sz="1300" b="1" dirty="0">
-                <a:solidFill>
-                  <a:srgbClr val="F59E0B"/>
-                </a:solidFill>
-                <a:latin typeface="Calibri" pitchFamily="34" charset="0"/>
-                <a:ea typeface="Calibri" pitchFamily="34" charset="-122"/>
-                <a:cs typeface="Calibri" pitchFamily="34" charset="-120"/>
-              </a:rPr>
-              <a:t>Paper: </a:t>
-            </a:r>
-            <a:r>
-              <a:rPr lang="en-US" sz="1300" dirty="0">
-                <a:solidFill>
-                  <a:srgbClr val="CADCFC"/>
-                </a:solidFill>
-                <a:latin typeface="Calibri" pitchFamily="34" charset="0"/>
-                <a:ea typeface="Calibri" pitchFamily="34" charset="-122"/>
-                <a:cs typeface="Calibri" pitchFamily="34" charset="-120"/>
-              </a:rPr>
-              <a:t>SolverLLM (NeurIPS 2025)  </a:t>
-            </a:r>
-            <a:r>
-              <a:rPr lang="en-US" sz="1300" dirty="0">
+              <a:t>Technical Report  </a:t>
+            </a:r>
+            <a:r>
+              <a:rPr lang="en-US" sz="1100">
                 <a:solidFill>
                   <a:srgbClr val="64748B"/>
                 </a:solidFill>
@@ -1447,60 +1613,10 @@
                 <a:ea typeface="Calibri" pitchFamily="34" charset="-122"/>
                 <a:cs typeface="Calibri" pitchFamily="34" charset="-120"/>
               </a:rPr>
-              <a:t>  |  </a:t>
-            </a:r>
-            <a:r>
-              <a:rPr lang="en-US" sz="1300" b="1" dirty="0">
-                <a:solidFill>
-                  <a:srgbClr val="F59E0B"/>
-                </a:solidFill>
-                <a:latin typeface="Calibri" pitchFamily="34" charset="0"/>
-                <a:ea typeface="Calibri" pitchFamily="34" charset="-122"/>
-                <a:cs typeface="Calibri" pitchFamily="34" charset="-120"/>
-              </a:rPr>
-              <a:t>Datasets: </a:t>
-            </a:r>
-            <a:r>
-              <a:rPr lang="en-US" sz="1300" dirty="0">
-                <a:solidFill>
-                  <a:srgbClr val="CADCFC"/>
-                </a:solidFill>
-                <a:latin typeface="Calibri" pitchFamily="34" charset="0"/>
-                <a:ea typeface="Calibri" pitchFamily="34" charset="-122"/>
-                <a:cs typeface="Calibri" pitchFamily="34" charset="-120"/>
-              </a:rPr>
-              <a:t>9 benchmarks, 2,634 problems</a:t>
-            </a:r>
-            <a:endParaRPr lang="en-US" sz="1300" dirty="0"/>
-          </a:p>
-        </p:txBody>
-      </p:sp>
-      <p:sp>
-        <p:nvSpPr>
-          <p:cNvPr id="8" name="Text 6"/>
-          <p:cNvSpPr/>
-          <p:nvPr/>
-        </p:nvSpPr>
-        <p:spPr>
-          <a:xfrm>
-            <a:off x="640080" y="4663440"/>
-            <a:ext cx="4572000" cy="320040"/>
-          </a:xfrm>
-          <a:prstGeom prst="rect">
-            <a:avLst/>
-          </a:prstGeom>
-          <a:noFill/>
-          <a:ln/>
-        </p:spPr>
-        <p:txBody>
-          <a:bodyPr wrap="square" lIns="0" tIns="0" rIns="0" bIns="0" rtlCol="0" anchor="ctr"/>
-          <a:lstStyle/>
-          <a:p>
-            <a:pPr marL="0" indent="0">
-              <a:buNone/>
-            </a:pPr>
-            <a:r>
-              <a:rPr lang="en-US" sz="1100" dirty="0">
+              <a:t>•  202</a:t>
+            </a:r>
+            <a:r>
+              <a:rPr lang="en-US" altLang="zh-CN" sz="1100">
                 <a:solidFill>
                   <a:srgbClr val="64748B"/>
                 </a:solidFill>
@@ -1508,7 +1624,7 @@
                 <a:ea typeface="Calibri" pitchFamily="34" charset="-122"/>
                 <a:cs typeface="Calibri" pitchFamily="34" charset="-120"/>
               </a:rPr>
-              <a:t>Technical Report  •  2025</a:t>
+              <a:t>6</a:t>
             </a:r>
             <a:endParaRPr lang="en-US" sz="1100" dirty="0"/>
           </a:p>
@@ -1594,7 +1710,7 @@
         </p:nvSpPr>
         <p:spPr>
           <a:xfrm>
-            <a:off x="6766560" y="3017520"/>
+            <a:off x="6812280" y="3020529"/>
             <a:ext cx="1097280" cy="1097280"/>
           </a:xfrm>
           <a:prstGeom prst="ellipse">

</xml_diff>